<commit_message>
refactor: use XmlSanitizer for document parsing
Replace raw XmlPullParser usage with XmlSanitizer across Excel and PowerPoint handlers to improve security and robustness when parsing untrusted document content.
</commit_message>
<xml_diff>
--- a/app/src/main/assets/samples/product_design_systems.pptx
+++ b/app/src/main/assets/samples/product_design_systems.pptx
@@ -76,25 +76,66 @@
 </p:sld>
 </file>
 
-<file path=ppt/slides/slide2.xml><?xml version="1.0" encoding="UTF-8" standalone="yes"?>
+<file path=ppt/slides/slide2.xml><?xml version="1.0" encoding="utf-8"?>
 <p:sld xmlns:p="http://schemas.openxmlformats.org/presentationml/2006/main" xmlns:a="http://schemas.openxmlformats.org/drawingml/2006/main">
   <p:cSld>
     <p:spTree>
-      <p:nvGrpSpPr><p:cNvPr id="1" name=""/><p:cNvGrpSpPr/><p:nvPr/></p:nvGrpSpPr>
+      <p:nvGrpSpPr>
+        <p:cNvPr id="1" name=""/>
+        <p:cNvGrpSpPr/>
+        <p:nvPr/>
+      </p:nvGrpSpPr>
       <p:grpSpPr/>
       <p:sp>
-        <p:nvSpPr><p:cNvPr id="2" name="Title"/><p:cNvSpPr><a:spLocks noGrp="1"/></p:cNvSpPr><p:nvPr/></p:nvSpPr>
-        <p:txBody>
-          <a:bodyPr/>
-          <a:p><a:r><a:t>Universal Format Architecture</a:t></a:r></a:p>
-          <a:p><a:r><a:t>Engineering reliability across document standards</a:t></a:r></a:p>
-        </p:txBody>
-      </p:sp>
-      <p:sp>
-        <p:nvSpPr><p:cNvPr id="3" name="Content"/><p:cNvSpPr><a:spLocks noGrp="1"/></p:cNvSpPr><p:nvPr/></p:nvSpPr>
-        <p:txBody>
-          <a:bodyPr/>
-          <a:p><a:pPr lvl="0"/><a:r><a:t>• PDF: Fast bitmap rendering with memory-safe paging</a:t></a:r></a:p><a:p><a:pPr lvl="0"/><a:r><a:t>• DOCX / PPTX / XLSX: Native ZIP OpenXML parsing</a:t></a:r></a:p><a:p><a:pPr lvl="0"/><a:r><a:t>• CSV & Markdown: Instant tokenized streaming grids</a:t></a:r></a:p>
+        <p:nvSpPr>
+          <p:cNvPr id="2" name="Title"/>
+          <p:cNvSpPr>
+            <a:spLocks noGrp="1"/>
+          </p:cNvSpPr>
+          <p:nvPr/>
+        </p:nvSpPr>
+        <p:txBody>
+          <a:bodyPr/>
+          <a:p>
+            <a:r>
+              <a:t>Universal Format Architecture</a:t>
+            </a:r>
+          </a:p>
+          <a:p>
+            <a:r>
+              <a:t>Engineering reliability across document standards</a:t>
+            </a:r>
+          </a:p>
+        </p:txBody>
+      </p:sp>
+      <p:sp>
+        <p:nvSpPr>
+          <p:cNvPr id="3" name="Content"/>
+          <p:cNvSpPr>
+            <a:spLocks noGrp="1"/>
+          </p:cNvSpPr>
+          <p:nvPr/>
+        </p:nvSpPr>
+        <p:txBody>
+          <a:bodyPr/>
+          <a:p>
+            <a:pPr lvl="0"/>
+            <a:r>
+              <a:t>• PDF: Fast bitmap rendering with memory-safe paging</a:t>
+            </a:r>
+          </a:p>
+          <a:p>
+            <a:pPr lvl="0"/>
+            <a:r>
+              <a:t>• DOCX / PPTX / XLSX: Native ZIP OpenXML parsing</a:t>
+            </a:r>
+          </a:p>
+          <a:p>
+            <a:pPr lvl="0"/>
+            <a:r>
+              <a:t>• CSV &amp; Markdown: Instant tokenized streaming grids</a:t>
+            </a:r>
+          </a:p>
         </p:txBody>
       </p:sp>
     </p:spTree>
@@ -102,25 +143,66 @@
 </p:sld>
 </file>
 
-<file path=ppt/slides/slide3.xml><?xml version="1.0" encoding="UTF-8" standalone="yes"?>
+<file path=ppt/slides/slide3.xml><?xml version="1.0" encoding="utf-8"?>
 <p:sld xmlns:p="http://schemas.openxmlformats.org/presentationml/2006/main" xmlns:a="http://schemas.openxmlformats.org/drawingml/2006/main">
   <p:cSld>
     <p:spTree>
-      <p:nvGrpSpPr><p:cNvPr id="1" name=""/><p:cNvGrpSpPr/><p:nvPr/></p:nvGrpSpPr>
+      <p:nvGrpSpPr>
+        <p:cNvPr id="1" name=""/>
+        <p:cNvGrpSpPr/>
+        <p:nvPr/>
+      </p:nvGrpSpPr>
       <p:grpSpPr/>
       <p:sp>
-        <p:nvSpPr><p:cNvPr id="2" name="Title"/><p:cNvSpPr><a:spLocks noGrp="1"/></p:cNvSpPr><p:nvPr/></p:nvSpPr>
-        <p:txBody>
-          <a:bodyPr/>
-          <a:p><a:r><a:t>Privacy & Performance Guarantees</a:t></a:r></a:p>
-          <a:p><a:r><a:t>Deterministic local execution</a:t></a:r></a:p>
-        </p:txBody>
-      </p:sp>
-      <p:sp>
-        <p:nvSpPr><p:cNvPr id="3" name="Content"/><p:cNvSpPr><a:spLocks noGrp="1"/></p:cNvSpPr><p:nvPr/></p:nvSpPr>
-        <p:txBody>
-          <a:bodyPr/>
-          <a:p><a:pPr lvl="0"/><a:r><a:t>• 100% offline document processing</a:t></a:r></a:p><a:p><a:pPr lvl="0"/><a:r><a:t>• No user telemetry or remote tracking</a:t></a:r></a:p><a:p><a:pPr lvl="0"/><a:r><a:t>• Room database persistence with URI permissions</a:t></a:r></a:p>
+        <p:nvSpPr>
+          <p:cNvPr id="2" name="Title"/>
+          <p:cNvSpPr>
+            <a:spLocks noGrp="1"/>
+          </p:cNvSpPr>
+          <p:nvPr/>
+        </p:nvSpPr>
+        <p:txBody>
+          <a:bodyPr/>
+          <a:p>
+            <a:r>
+              <a:t>Privacy &amp; Performance Guarantees</a:t>
+            </a:r>
+          </a:p>
+          <a:p>
+            <a:r>
+              <a:t>Deterministic local execution</a:t>
+            </a:r>
+          </a:p>
+        </p:txBody>
+      </p:sp>
+      <p:sp>
+        <p:nvSpPr>
+          <p:cNvPr id="3" name="Content"/>
+          <p:cNvSpPr>
+            <a:spLocks noGrp="1"/>
+          </p:cNvSpPr>
+          <p:nvPr/>
+        </p:nvSpPr>
+        <p:txBody>
+          <a:bodyPr/>
+          <a:p>
+            <a:pPr lvl="0"/>
+            <a:r>
+              <a:t>• 100% offline document processing</a:t>
+            </a:r>
+          </a:p>
+          <a:p>
+            <a:pPr lvl="0"/>
+            <a:r>
+              <a:t>• No user telemetry or remote tracking</a:t>
+            </a:r>
+          </a:p>
+          <a:p>
+            <a:pPr lvl="0"/>
+            <a:r>
+              <a:t>• Room database persistence with URI permissions</a:t>
+            </a:r>
+          </a:p>
         </p:txBody>
       </p:sp>
     </p:spTree>

</xml_diff>